<commit_message>
labs for topic 08
</commit_message>
<xml_diff>
--- a/topic08-arrays-of-objects/unit-1/talk-1-shop-v1/a-shop-v1.pptx
+++ b/topic08-arrays-of-objects/unit-1/talk-1-shop-v1/a-shop-v1.pptx
@@ -243,7 +243,7 @@
           <a:p>
             <a:fld id="{56BC3C30-7F3D-4B20-9974-47C57B22CA6E}" type="datetimeFigureOut">
               <a:rPr lang="en-IE" smtClean="0"/>
-              <a:t>03/11/2025</a:t>
+              <a:t>08/11/2025</a:t>
             </a:fld>
             <a:endParaRPr lang="en-IE"/>
           </a:p>
@@ -1598,7 +1598,7 @@
             <a:fld id="{1D8BD707-D9CF-40AE-B4C6-C98DA3205C09}" type="datetimeFigureOut">
               <a:rPr lang="en-US" smtClean="0"/>
               <a:pPr/>
-              <a:t>11/3/25</a:t>
+              <a:t>11/8/25</a:t>
             </a:fld>
             <a:endParaRPr lang="en-US"/>
           </a:p>
@@ -1770,7 +1770,7 @@
             <a:fld id="{1D8BD707-D9CF-40AE-B4C6-C98DA3205C09}" type="datetimeFigureOut">
               <a:rPr lang="en-US" smtClean="0"/>
               <a:pPr/>
-              <a:t>11/3/25</a:t>
+              <a:t>11/8/25</a:t>
             </a:fld>
             <a:endParaRPr lang="en-US"/>
           </a:p>
@@ -1952,7 +1952,7 @@
             <a:fld id="{1D8BD707-D9CF-40AE-B4C6-C98DA3205C09}" type="datetimeFigureOut">
               <a:rPr lang="en-US" smtClean="0"/>
               <a:pPr/>
-              <a:t>11/3/25</a:t>
+              <a:t>11/8/25</a:t>
             </a:fld>
             <a:endParaRPr lang="en-US"/>
           </a:p>
@@ -2591,7 +2591,7 @@
             <a:fld id="{1D8BD707-D9CF-40AE-B4C6-C98DA3205C09}" type="datetimeFigureOut">
               <a:rPr lang="en-US" smtClean="0"/>
               <a:pPr/>
-              <a:t>11/3/25</a:t>
+              <a:t>11/8/25</a:t>
             </a:fld>
             <a:endParaRPr lang="en-US"/>
           </a:p>
@@ -3097,7 +3097,7 @@
             <a:fld id="{1D8BD707-D9CF-40AE-B4C6-C98DA3205C09}" type="datetimeFigureOut">
               <a:rPr lang="en-US" smtClean="0"/>
               <a:pPr/>
-              <a:t>11/3/25</a:t>
+              <a:t>11/8/25</a:t>
             </a:fld>
             <a:endParaRPr lang="en-US"/>
           </a:p>
@@ -3398,7 +3398,7 @@
             <a:fld id="{1D8BD707-D9CF-40AE-B4C6-C98DA3205C09}" type="datetimeFigureOut">
               <a:rPr lang="en-US" smtClean="0"/>
               <a:pPr/>
-              <a:t>11/3/25</a:t>
+              <a:t>11/8/25</a:t>
             </a:fld>
             <a:endParaRPr lang="en-US"/>
           </a:p>
@@ -4069,7 +4069,7 @@
             <a:fld id="{1D8BD707-D9CF-40AE-B4C6-C98DA3205C09}" type="datetimeFigureOut">
               <a:rPr lang="en-US" smtClean="0"/>
               <a:pPr/>
-              <a:t>11/3/25</a:t>
+              <a:t>11/8/25</a:t>
             </a:fld>
             <a:endParaRPr lang="en-US"/>
           </a:p>
@@ -4399,7 +4399,7 @@
             <a:fld id="{1D8BD707-D9CF-40AE-B4C6-C98DA3205C09}" type="datetimeFigureOut">
               <a:rPr lang="en-US" smtClean="0"/>
               <a:pPr/>
-              <a:t>11/3/25</a:t>
+              <a:t>11/8/25</a:t>
             </a:fld>
             <a:endParaRPr lang="en-US"/>
           </a:p>
@@ -4736,7 +4736,7 @@
             <a:fld id="{1D8BD707-D9CF-40AE-B4C6-C98DA3205C09}" type="datetimeFigureOut">
               <a:rPr lang="en-US" smtClean="0"/>
               <a:pPr/>
-              <a:t>11/3/25</a:t>
+              <a:t>11/8/25</a:t>
             </a:fld>
             <a:endParaRPr lang="en-US"/>
           </a:p>
@@ -5015,7 +5015,7 @@
             <a:fld id="{1D8BD707-D9CF-40AE-B4C6-C98DA3205C09}" type="datetimeFigureOut">
               <a:rPr lang="en-US" smtClean="0"/>
               <a:pPr/>
-              <a:t>11/3/25</a:t>
+              <a:t>11/8/25</a:t>
             </a:fld>
             <a:endParaRPr lang="en-US"/>
           </a:p>
@@ -5274,7 +5274,7 @@
             <a:fld id="{1D8BD707-D9CF-40AE-B4C6-C98DA3205C09}" type="datetimeFigureOut">
               <a:rPr lang="en-US" smtClean="0"/>
               <a:pPr/>
-              <a:t>11/3/25</a:t>
+              <a:t>11/8/25</a:t>
             </a:fld>
             <a:endParaRPr lang="en-US"/>
           </a:p>
@@ -5494,7 +5494,7 @@
             <a:fld id="{1D8BD707-D9CF-40AE-B4C6-C98DA3205C09}" type="datetimeFigureOut">
               <a:rPr lang="en-US" smtClean="0"/>
               <a:pPr/>
-              <a:t>11/3/25</a:t>
+              <a:t>11/8/25</a:t>
             </a:fld>
             <a:endParaRPr lang="en-US"/>
           </a:p>
@@ -6260,10 +6260,10 @@
       </p:grpSpPr>
       <p:pic>
         <p:nvPicPr>
-          <p:cNvPr id="8" name="Picture 7">
+          <p:cNvPr id="3" name="Picture 2">
             <a:extLst>
               <a:ext uri="{FF2B5EF4-FFF2-40B4-BE49-F238E27FC236}">
-                <a16:creationId xmlns:a16="http://schemas.microsoft.com/office/drawing/2014/main" id="{6A137E3E-B90D-E7C0-8841-6C916F45AAC0}"/>
+                <a16:creationId xmlns:a16="http://schemas.microsoft.com/office/drawing/2014/main" id="{EB7DB27C-5B6D-D51A-C0E9-942B94B4A2CD}"/>
               </a:ext>
             </a:extLst>
           </p:cNvPr>
@@ -6280,8 +6280,8 @@
         </p:blipFill>
         <p:spPr>
           <a:xfrm>
-            <a:off x="5467350" y="1544018"/>
-            <a:ext cx="5524500" cy="2628900"/>
+            <a:off x="5334000" y="1752600"/>
+            <a:ext cx="5181600" cy="2527300"/>
           </a:xfrm>
           <a:prstGeom prst="rect">
             <a:avLst/>
@@ -6627,10 +6627,10 @@
       </p:grpSpPr>
       <p:pic>
         <p:nvPicPr>
-          <p:cNvPr id="10" name="Picture 9">
+          <p:cNvPr id="3" name="Picture 2">
             <a:extLst>
               <a:ext uri="{FF2B5EF4-FFF2-40B4-BE49-F238E27FC236}">
-                <a16:creationId xmlns:a16="http://schemas.microsoft.com/office/drawing/2014/main" id="{9392D32B-5532-698A-6B91-153924162387}"/>
+                <a16:creationId xmlns:a16="http://schemas.microsoft.com/office/drawing/2014/main" id="{E91E0EE9-7F4A-66C0-EC47-219DB3018595}"/>
               </a:ext>
             </a:extLst>
           </p:cNvPr>
@@ -6647,8 +6647,8 @@
         </p:blipFill>
         <p:spPr>
           <a:xfrm>
-            <a:off x="4953000" y="1747486"/>
-            <a:ext cx="5524500" cy="2628900"/>
+            <a:off x="5029924" y="1726146"/>
+            <a:ext cx="5181600" cy="2527300"/>
           </a:xfrm>
           <a:prstGeom prst="rect">
             <a:avLst/>
@@ -7105,10 +7105,10 @@
       </p:grpSpPr>
       <p:pic>
         <p:nvPicPr>
-          <p:cNvPr id="18" name="Picture 17">
+          <p:cNvPr id="3" name="Picture 2">
             <a:extLst>
               <a:ext uri="{FF2B5EF4-FFF2-40B4-BE49-F238E27FC236}">
-                <a16:creationId xmlns:a16="http://schemas.microsoft.com/office/drawing/2014/main" id="{B659F0F3-481F-3DCB-B115-319728DDAB77}"/>
+                <a16:creationId xmlns:a16="http://schemas.microsoft.com/office/drawing/2014/main" id="{639D256D-90A7-1CCF-869E-BE00B583BC44}"/>
               </a:ext>
             </a:extLst>
           </p:cNvPr>
@@ -7125,8 +7125,8 @@
         </p:blipFill>
         <p:spPr>
           <a:xfrm>
-            <a:off x="5547944" y="763067"/>
-            <a:ext cx="5524500" cy="2628900"/>
+            <a:off x="5511055" y="916586"/>
+            <a:ext cx="5181600" cy="2527300"/>
           </a:xfrm>
           <a:prstGeom prst="rect">
             <a:avLst/>
@@ -9484,10 +9484,10 @@
       </p:grpSpPr>
       <p:pic>
         <p:nvPicPr>
-          <p:cNvPr id="5" name="Picture 4">
+          <p:cNvPr id="3" name="Picture 2">
             <a:extLst>
               <a:ext uri="{FF2B5EF4-FFF2-40B4-BE49-F238E27FC236}">
-                <a16:creationId xmlns:a16="http://schemas.microsoft.com/office/drawing/2014/main" id="{88D2545D-9B83-2994-0B42-3F537BC0B35A}"/>
+                <a16:creationId xmlns:a16="http://schemas.microsoft.com/office/drawing/2014/main" id="{8A6923CC-E46C-F955-5B28-FAA755917B6A}"/>
               </a:ext>
             </a:extLst>
           </p:cNvPr>
@@ -9504,8 +9504,8 @@
         </p:blipFill>
         <p:spPr>
           <a:xfrm>
-            <a:off x="4114845" y="1417638"/>
-            <a:ext cx="6516468" cy="3100940"/>
+            <a:off x="4114845" y="1265459"/>
+            <a:ext cx="6718815" cy="3277069"/>
           </a:xfrm>
           <a:prstGeom prst="rect">
             <a:avLst/>
@@ -9840,10 +9840,10 @@
       </p:grpSpPr>
       <p:pic>
         <p:nvPicPr>
-          <p:cNvPr id="7" name="Picture 6">
+          <p:cNvPr id="3" name="Picture 2">
             <a:extLst>
               <a:ext uri="{FF2B5EF4-FFF2-40B4-BE49-F238E27FC236}">
-                <a16:creationId xmlns:a16="http://schemas.microsoft.com/office/drawing/2014/main" id="{60FA7A46-C891-77A0-E067-DF3DA29BE155}"/>
+                <a16:creationId xmlns:a16="http://schemas.microsoft.com/office/drawing/2014/main" id="{24A0D1C7-9D08-943D-43B6-D9E6817575C6}"/>
               </a:ext>
             </a:extLst>
           </p:cNvPr>
@@ -9860,8 +9860,8 @@
         </p:blipFill>
         <p:spPr>
           <a:xfrm>
-            <a:off x="4344649" y="1417638"/>
-            <a:ext cx="7285935" cy="3467100"/>
+            <a:off x="4168291" y="1143000"/>
+            <a:ext cx="7811457" cy="3810000"/>
           </a:xfrm>
           <a:prstGeom prst="rect">
             <a:avLst/>
@@ -10324,10 +10324,10 @@
       </p:grpSpPr>
       <p:pic>
         <p:nvPicPr>
-          <p:cNvPr id="7" name="Picture 6">
+          <p:cNvPr id="3" name="Picture 2">
             <a:extLst>
               <a:ext uri="{FF2B5EF4-FFF2-40B4-BE49-F238E27FC236}">
-                <a16:creationId xmlns:a16="http://schemas.microsoft.com/office/drawing/2014/main" id="{BCE06BCD-012C-1070-B8E2-101CB68C7013}"/>
+                <a16:creationId xmlns:a16="http://schemas.microsoft.com/office/drawing/2014/main" id="{9E559DF2-B239-B28D-9892-4FAF7D66C9BB}"/>
               </a:ext>
             </a:extLst>
           </p:cNvPr>
@@ -10344,8 +10344,8 @@
         </p:blipFill>
         <p:spPr>
           <a:xfrm>
-            <a:off x="4392406" y="1201266"/>
-            <a:ext cx="6923294" cy="3294533"/>
+            <a:off x="3548090" y="1178866"/>
+            <a:ext cx="9686207" cy="4724400"/>
           </a:xfrm>
           <a:prstGeom prst="rect">
             <a:avLst/>
@@ -10444,8 +10444,8 @@
         </p:nvSpPr>
         <p:spPr>
           <a:xfrm>
-            <a:off x="4392406" y="2933700"/>
-            <a:ext cx="3303794" cy="607366"/>
+            <a:off x="3556798" y="3641286"/>
+            <a:ext cx="3987001" cy="930714"/>
           </a:xfrm>
           <a:prstGeom prst="roundRect">
             <a:avLst/>
@@ -10489,7 +10489,7 @@
         <p:spPr>
           <a:xfrm>
             <a:off x="2615304" y="1957962"/>
-            <a:ext cx="1777102" cy="1143000"/>
+            <a:ext cx="1118496" cy="1775838"/>
           </a:xfrm>
           <a:prstGeom prst="straightConnector1">
             <a:avLst/>
@@ -13355,10 +13355,10 @@
       </p:grpSpPr>
       <p:pic>
         <p:nvPicPr>
-          <p:cNvPr id="7" name="Picture 6">
+          <p:cNvPr id="3" name="Picture 2">
             <a:extLst>
               <a:ext uri="{FF2B5EF4-FFF2-40B4-BE49-F238E27FC236}">
-                <a16:creationId xmlns:a16="http://schemas.microsoft.com/office/drawing/2014/main" id="{4A1B2888-D905-B926-1257-69C85656A775}"/>
+                <a16:creationId xmlns:a16="http://schemas.microsoft.com/office/drawing/2014/main" id="{D68ED950-9CE4-D554-1088-4244596595D7}"/>
               </a:ext>
             </a:extLst>
           </p:cNvPr>
@@ -13375,8 +13375,8 @@
         </p:blipFill>
         <p:spPr>
           <a:xfrm>
-            <a:off x="4863685" y="1768917"/>
-            <a:ext cx="7328315" cy="3487267"/>
+            <a:off x="4876800" y="1143000"/>
+            <a:ext cx="8763192" cy="4274204"/>
           </a:xfrm>
           <a:prstGeom prst="rect">
             <a:avLst/>
@@ -13476,7 +13476,7 @@
         <p:spPr>
           <a:xfrm>
             <a:off x="5067300" y="4202393"/>
-            <a:ext cx="4610100" cy="750607"/>
+            <a:ext cx="5676900" cy="826807"/>
           </a:xfrm>
           <a:prstGeom prst="roundRect">
             <a:avLst/>
@@ -18701,36 +18701,6 @@
           <a:chExt cx="0" cy="0"/>
         </a:xfrm>
       </p:grpSpPr>
-      <p:pic>
-        <p:nvPicPr>
-          <p:cNvPr id="6" name="Picture 5">
-            <a:extLst>
-              <a:ext uri="{FF2B5EF4-FFF2-40B4-BE49-F238E27FC236}">
-                <a16:creationId xmlns:a16="http://schemas.microsoft.com/office/drawing/2014/main" id="{0BDFB783-CFC0-9D1F-34B2-973CB5675F49}"/>
-              </a:ext>
-            </a:extLst>
-          </p:cNvPr>
-          <p:cNvPicPr>
-            <a:picLocks noChangeAspect="1"/>
-          </p:cNvPicPr>
-          <p:nvPr/>
-        </p:nvPicPr>
-        <p:blipFill>
-          <a:blip r:embed="rId3"/>
-          <a:stretch>
-            <a:fillRect/>
-          </a:stretch>
-        </p:blipFill>
-        <p:spPr>
-          <a:xfrm>
-            <a:off x="3657600" y="1529542"/>
-            <a:ext cx="8153400" cy="4213574"/>
-          </a:xfrm>
-          <a:prstGeom prst="rect">
-            <a:avLst/>
-          </a:prstGeom>
-        </p:spPr>
-      </p:pic>
       <p:graphicFrame>
         <p:nvGraphicFramePr>
           <p:cNvPr id="4" name="Table 3">
@@ -18984,6 +18954,36 @@
           </a:fontRef>
         </p:style>
       </p:cxnSp>
+      <p:pic>
+        <p:nvPicPr>
+          <p:cNvPr id="3" name="Picture 2">
+            <a:extLst>
+              <a:ext uri="{FF2B5EF4-FFF2-40B4-BE49-F238E27FC236}">
+                <a16:creationId xmlns:a16="http://schemas.microsoft.com/office/drawing/2014/main" id="{34D394E0-9F2F-27D7-22D3-ED4E01D518B0}"/>
+              </a:ext>
+            </a:extLst>
+          </p:cNvPr>
+          <p:cNvPicPr>
+            <a:picLocks noChangeAspect="1"/>
+          </p:cNvPicPr>
+          <p:nvPr/>
+        </p:nvPicPr>
+        <p:blipFill>
+          <a:blip r:embed="rId3"/>
+          <a:stretch>
+            <a:fillRect/>
+          </a:stretch>
+        </p:blipFill>
+        <p:spPr>
+          <a:xfrm>
+            <a:off x="4249783" y="1923130"/>
+            <a:ext cx="9522753" cy="4644676"/>
+          </a:xfrm>
+          <a:prstGeom prst="rect">
+            <a:avLst/>
+          </a:prstGeom>
+        </p:spPr>
+      </p:pic>
     </p:spTree>
     <p:extLst>
       <p:ext uri="{BB962C8B-B14F-4D97-AF65-F5344CB8AC3E}">
@@ -20176,10 +20176,10 @@
       </p:grpSpPr>
       <p:pic>
         <p:nvPicPr>
-          <p:cNvPr id="9" name="Picture 8">
+          <p:cNvPr id="3" name="Picture 2">
             <a:extLst>
               <a:ext uri="{FF2B5EF4-FFF2-40B4-BE49-F238E27FC236}">
-                <a16:creationId xmlns:a16="http://schemas.microsoft.com/office/drawing/2014/main" id="{9CD84F55-55DC-D206-8DA9-5FB64F4C754A}"/>
+                <a16:creationId xmlns:a16="http://schemas.microsoft.com/office/drawing/2014/main" id="{10B80157-96A0-FB64-2D5D-D4A4DA266EA3}"/>
               </a:ext>
             </a:extLst>
           </p:cNvPr>
@@ -20196,8 +20196,8 @@
         </p:blipFill>
         <p:spPr>
           <a:xfrm>
-            <a:off x="4905611" y="1417422"/>
-            <a:ext cx="7395246" cy="3519117"/>
+            <a:off x="4934309" y="1676400"/>
+            <a:ext cx="7967686" cy="3886200"/>
           </a:xfrm>
           <a:prstGeom prst="rect">
             <a:avLst/>
@@ -20516,9 +20516,9 @@
           <p:nvPr/>
         </p:nvCxnSpPr>
         <p:spPr>
-          <a:xfrm flipV="1">
-            <a:off x="3200400" y="3349276"/>
-            <a:ext cx="2133600" cy="3524"/>
+          <a:xfrm>
+            <a:off x="3200400" y="3352800"/>
+            <a:ext cx="1712138" cy="1147305"/>
           </a:xfrm>
           <a:prstGeom prst="straightConnector1">
             <a:avLst/>
@@ -21021,10 +21021,10 @@
       </p:grpSpPr>
       <p:pic>
         <p:nvPicPr>
-          <p:cNvPr id="6" name="Picture 5">
+          <p:cNvPr id="3" name="Picture 2">
             <a:extLst>
               <a:ext uri="{FF2B5EF4-FFF2-40B4-BE49-F238E27FC236}">
-                <a16:creationId xmlns:a16="http://schemas.microsoft.com/office/drawing/2014/main" id="{6C5755CF-E455-A263-6CA2-058E5FD66087}"/>
+                <a16:creationId xmlns:a16="http://schemas.microsoft.com/office/drawing/2014/main" id="{5307DD5E-631A-DB71-33E6-F7C119DECEB8}"/>
               </a:ext>
             </a:extLst>
           </p:cNvPr>
@@ -21041,8 +21041,8 @@
         </p:blipFill>
         <p:spPr>
           <a:xfrm>
-            <a:off x="5847388" y="1738273"/>
-            <a:ext cx="6440823" cy="3519117"/>
+            <a:off x="5847806" y="1517865"/>
+            <a:ext cx="9457657" cy="4612926"/>
           </a:xfrm>
           <a:prstGeom prst="rect">
             <a:avLst/>
@@ -21492,13 +21492,14 @@
           </p:cNvPr>
           <p:cNvCxnSpPr>
             <a:cxnSpLocks/>
+            <a:endCxn id="16" idx="1"/>
           </p:cNvCxnSpPr>
           <p:nvPr/>
         </p:nvCxnSpPr>
         <p:spPr>
-          <a:xfrm flipV="1">
-            <a:off x="3200400" y="3349276"/>
-            <a:ext cx="2133600" cy="3524"/>
+          <a:xfrm>
+            <a:off x="4907282" y="2218508"/>
+            <a:ext cx="1036317" cy="561030"/>
           </a:xfrm>
           <a:prstGeom prst="straightConnector1">
             <a:avLst/>
@@ -21541,8 +21542,8 @@
         </p:nvCxnSpPr>
         <p:spPr>
           <a:xfrm flipV="1">
-            <a:off x="4887688" y="2804001"/>
-            <a:ext cx="1436913" cy="1422012"/>
+            <a:off x="4887688" y="3033672"/>
+            <a:ext cx="1086394" cy="1192341"/>
           </a:xfrm>
           <a:prstGeom prst="straightConnector1">
             <a:avLst/>
@@ -21585,8 +21586,8 @@
         </p:nvCxnSpPr>
         <p:spPr>
           <a:xfrm flipV="1">
-            <a:off x="4887688" y="3352802"/>
-            <a:ext cx="979712" cy="1828799"/>
+            <a:off x="4887688" y="4384762"/>
+            <a:ext cx="979712" cy="796839"/>
           </a:xfrm>
           <a:prstGeom prst="straightConnector1">
             <a:avLst/>
@@ -21667,8 +21668,8 @@
         </p:nvSpPr>
         <p:spPr>
           <a:xfrm>
-            <a:off x="5903340" y="3562396"/>
-            <a:ext cx="4368726" cy="1288143"/>
+            <a:off x="5974082" y="3943477"/>
+            <a:ext cx="5989318" cy="1828799"/>
           </a:xfrm>
           <a:prstGeom prst="rect">
             <a:avLst/>
@@ -21720,9 +21721,9 @@
           <p:nvPr/>
         </p:nvCxnSpPr>
         <p:spPr>
-          <a:xfrm flipV="1">
-            <a:off x="4887688" y="4144966"/>
-            <a:ext cx="1055910" cy="1036634"/>
+          <a:xfrm>
+            <a:off x="4887688" y="5181600"/>
+            <a:ext cx="979712" cy="0"/>
           </a:xfrm>
           <a:prstGeom prst="straightConnector1">
             <a:avLst/>
@@ -27787,10 +27788,10 @@
       </p:grpSpPr>
       <p:pic>
         <p:nvPicPr>
-          <p:cNvPr id="25" name="Picture 24">
+          <p:cNvPr id="3" name="Picture 2">
             <a:extLst>
               <a:ext uri="{FF2B5EF4-FFF2-40B4-BE49-F238E27FC236}">
-                <a16:creationId xmlns:a16="http://schemas.microsoft.com/office/drawing/2014/main" id="{2F776987-7941-F89E-2525-7BDB37700D10}"/>
+                <a16:creationId xmlns:a16="http://schemas.microsoft.com/office/drawing/2014/main" id="{95F8E40A-BD9C-FA7E-E71C-9C64BE6D6D78}"/>
               </a:ext>
             </a:extLst>
           </p:cNvPr>
@@ -27807,8 +27808,8 @@
         </p:blipFill>
         <p:spPr>
           <a:xfrm>
-            <a:off x="5614035" y="1709865"/>
-            <a:ext cx="5524500" cy="2628900"/>
+            <a:off x="5795963" y="2032971"/>
+            <a:ext cx="5181600" cy="2527300"/>
           </a:xfrm>
           <a:prstGeom prst="rect">
             <a:avLst/>
@@ -27998,7 +27999,7 @@
         <p:spPr>
           <a:xfrm>
             <a:off x="4457614" y="2162204"/>
-            <a:ext cx="3512105" cy="99174"/>
+            <a:ext cx="3619586" cy="76635"/>
           </a:xfrm>
           <a:prstGeom prst="straightConnector1">
             <a:avLst/>
@@ -28072,7 +28073,7 @@
             <a:pPr algn="ctr"/>
             <a:r>
               <a:rPr lang="en-IE" sz="2400" dirty="0"/>
-              <a:t>The ‘+’ means it is </a:t>
+              <a:t>The green circle means it is </a:t>
             </a:r>
             <a:r>
               <a:rPr lang="en-IE" sz="2400" b="1" dirty="0"/>
@@ -28287,7 +28288,7 @@
             <a:pPr algn="ctr"/>
             <a:r>
               <a:rPr lang="en-IE" sz="2400" dirty="0"/>
-              <a:t>The ‘-’ means it is </a:t>
+              <a:t>The red box means it is </a:t>
             </a:r>
             <a:r>
               <a:rPr lang="en-IE" sz="2400" b="1" dirty="0"/>
@@ -28316,8 +28317,8 @@
         </p:nvCxnSpPr>
         <p:spPr>
           <a:xfrm flipV="1">
-            <a:off x="5098156" y="2538161"/>
-            <a:ext cx="567937" cy="955882"/>
+            <a:off x="5098156" y="2695429"/>
+            <a:ext cx="697807" cy="798614"/>
           </a:xfrm>
           <a:prstGeom prst="straightConnector1">
             <a:avLst/>

</xml_diff>

<commit_message>
update topic 08 and fix uml diagrams]
</commit_message>
<xml_diff>
--- a/topic08-arrays-of-objects/unit-1/talk-1-shop-v1/a-shop-v1.pptx
+++ b/topic08-arrays-of-objects/unit-1/talk-1-shop-v1/a-shop-v1.pptx
@@ -6260,10 +6260,10 @@
       </p:grpSpPr>
       <p:pic>
         <p:nvPicPr>
-          <p:cNvPr id="3" name="Picture 2">
+          <p:cNvPr id="4" name="Picture 3">
             <a:extLst>
               <a:ext uri="{FF2B5EF4-FFF2-40B4-BE49-F238E27FC236}">
-                <a16:creationId xmlns:a16="http://schemas.microsoft.com/office/drawing/2014/main" id="{EB7DB27C-5B6D-D51A-C0E9-942B94B4A2CD}"/>
+                <a16:creationId xmlns:a16="http://schemas.microsoft.com/office/drawing/2014/main" id="{E541BDBC-85DC-BBFC-1D6A-BF2D71E6EF43}"/>
               </a:ext>
             </a:extLst>
           </p:cNvPr>
@@ -6280,8 +6280,8 @@
         </p:blipFill>
         <p:spPr>
           <a:xfrm>
-            <a:off x="5334000" y="1752600"/>
-            <a:ext cx="5181600" cy="2527300"/>
+            <a:off x="5308602" y="1417638"/>
+            <a:ext cx="4165600" cy="4419600"/>
           </a:xfrm>
           <a:prstGeom prst="rect">
             <a:avLst/>
@@ -6402,7 +6402,7 @@
         <p:spPr>
           <a:xfrm>
             <a:off x="5334000" y="2133600"/>
-            <a:ext cx="2362201" cy="609600"/>
+            <a:ext cx="3276600" cy="914400"/>
           </a:xfrm>
           <a:prstGeom prst="roundRect">
             <a:avLst/>
@@ -6451,7 +6451,7 @@
         <p:spPr>
           <a:xfrm>
             <a:off x="4267201" y="2356860"/>
-            <a:ext cx="1066799" cy="81540"/>
+            <a:ext cx="1066799" cy="233940"/>
           </a:xfrm>
           <a:prstGeom prst="straightConnector1">
             <a:avLst/>
@@ -6627,10 +6627,10 @@
       </p:grpSpPr>
       <p:pic>
         <p:nvPicPr>
-          <p:cNvPr id="3" name="Picture 2">
+          <p:cNvPr id="4" name="Picture 3">
             <a:extLst>
               <a:ext uri="{FF2B5EF4-FFF2-40B4-BE49-F238E27FC236}">
-                <a16:creationId xmlns:a16="http://schemas.microsoft.com/office/drawing/2014/main" id="{E91E0EE9-7F4A-66C0-EC47-219DB3018595}"/>
+                <a16:creationId xmlns:a16="http://schemas.microsoft.com/office/drawing/2014/main" id="{5265D5F7-1A58-4EC0-7EC8-AECF0FFCB272}"/>
               </a:ext>
             </a:extLst>
           </p:cNvPr>
@@ -6647,8 +6647,8 @@
         </p:blipFill>
         <p:spPr>
           <a:xfrm>
-            <a:off x="5029924" y="1726146"/>
-            <a:ext cx="5181600" cy="2527300"/>
+            <a:off x="4927602" y="1417638"/>
+            <a:ext cx="4165600" cy="4419600"/>
           </a:xfrm>
           <a:prstGeom prst="rect">
             <a:avLst/>
@@ -6818,13 +6818,14 @@
           </p:cNvPr>
           <p:cNvCxnSpPr>
             <a:cxnSpLocks/>
+            <a:stCxn id="18" idx="3"/>
           </p:cNvCxnSpPr>
           <p:nvPr/>
         </p:nvCxnSpPr>
         <p:spPr>
           <a:xfrm flipV="1">
-            <a:off x="3549356" y="2550592"/>
-            <a:ext cx="2241844" cy="878408"/>
+            <a:off x="3545842" y="2365747"/>
+            <a:ext cx="2734602" cy="1063253"/>
           </a:xfrm>
           <a:prstGeom prst="straightConnector1">
             <a:avLst/>
@@ -6868,7 +6869,7 @@
         <p:spPr>
           <a:xfrm>
             <a:off x="3796025" y="1699591"/>
-            <a:ext cx="1385575" cy="719343"/>
+            <a:ext cx="1690375" cy="562494"/>
           </a:xfrm>
           <a:prstGeom prst="straightConnector1">
             <a:avLst/>
@@ -7105,10 +7106,10 @@
       </p:grpSpPr>
       <p:pic>
         <p:nvPicPr>
-          <p:cNvPr id="3" name="Picture 2">
+          <p:cNvPr id="4" name="Picture 3">
             <a:extLst>
               <a:ext uri="{FF2B5EF4-FFF2-40B4-BE49-F238E27FC236}">
-                <a16:creationId xmlns:a16="http://schemas.microsoft.com/office/drawing/2014/main" id="{639D256D-90A7-1CCF-869E-BE00B583BC44}"/>
+                <a16:creationId xmlns:a16="http://schemas.microsoft.com/office/drawing/2014/main" id="{B7FD41E1-833E-3659-4C28-E8A7C68596E9}"/>
               </a:ext>
             </a:extLst>
           </p:cNvPr>
@@ -7125,8 +7126,8 @@
         </p:blipFill>
         <p:spPr>
           <a:xfrm>
-            <a:off x="5511055" y="916586"/>
-            <a:ext cx="5181600" cy="2527300"/>
+            <a:off x="6119895" y="906031"/>
+            <a:ext cx="4165600" cy="4419600"/>
           </a:xfrm>
           <a:prstGeom prst="rect">
             <a:avLst/>
@@ -7244,8 +7245,8 @@
         </p:nvSpPr>
         <p:spPr>
           <a:xfrm>
-            <a:off x="5561840" y="1906067"/>
-            <a:ext cx="5334760" cy="274169"/>
+            <a:off x="6230413" y="2752149"/>
+            <a:ext cx="4165600" cy="256040"/>
           </a:xfrm>
           <a:prstGeom prst="roundRect">
             <a:avLst/>
@@ -7332,8 +7333,8 @@
         </p:nvSpPr>
         <p:spPr>
           <a:xfrm>
-            <a:off x="281259" y="4016345"/>
-            <a:ext cx="4572000" cy="400110"/>
+            <a:off x="862780" y="4870754"/>
+            <a:ext cx="3570005" cy="707886"/>
           </a:xfrm>
           <a:prstGeom prst="rect">
             <a:avLst/>
@@ -7395,8 +7396,8 @@
         </p:nvSpPr>
         <p:spPr>
           <a:xfrm>
-            <a:off x="7823627" y="5486400"/>
-            <a:ext cx="2620254" cy="707886"/>
+            <a:off x="7978031" y="5792953"/>
+            <a:ext cx="2046002" cy="1015663"/>
           </a:xfrm>
           <a:prstGeom prst="rect">
             <a:avLst/>
@@ -7475,8 +7476,8 @@
         </p:nvCxnSpPr>
         <p:spPr>
           <a:xfrm flipV="1">
-            <a:off x="2460009" y="2108200"/>
-            <a:ext cx="3293331" cy="1908145"/>
+            <a:off x="3352800" y="2880169"/>
+            <a:ext cx="3063640" cy="1990585"/>
           </a:xfrm>
           <a:prstGeom prst="straightConnector1">
             <a:avLst/>
@@ -7514,14 +7515,13 @@
           </p:cNvPr>
           <p:cNvCxnSpPr>
             <a:cxnSpLocks/>
-            <a:stCxn id="17" idx="0"/>
           </p:cNvCxnSpPr>
           <p:nvPr/>
         </p:nvCxnSpPr>
         <p:spPr>
           <a:xfrm flipH="1" flipV="1">
-            <a:off x="6882412" y="2165453"/>
-            <a:ext cx="2251342" cy="3320947"/>
+            <a:off x="7619061" y="3008189"/>
+            <a:ext cx="1354954" cy="2769981"/>
           </a:xfrm>
           <a:prstGeom prst="straightConnector1">
             <a:avLst/>
@@ -7565,8 +7565,8 @@
         </p:nvCxnSpPr>
         <p:spPr>
           <a:xfrm flipH="1" flipV="1">
-            <a:off x="8065912" y="2150670"/>
-            <a:ext cx="1067842" cy="3335730"/>
+            <a:off x="7978031" y="3008189"/>
+            <a:ext cx="1023001" cy="2784764"/>
           </a:xfrm>
           <a:prstGeom prst="straightConnector1">
             <a:avLst/>
@@ -7610,8 +7610,8 @@
         </p:nvCxnSpPr>
         <p:spPr>
           <a:xfrm flipH="1" flipV="1">
-            <a:off x="9120510" y="2180236"/>
-            <a:ext cx="13244" cy="3306164"/>
+            <a:off x="8610600" y="3008189"/>
+            <a:ext cx="390432" cy="2784764"/>
           </a:xfrm>
           <a:prstGeom prst="straightConnector1">
             <a:avLst/>
@@ -7655,8 +7655,8 @@
         </p:nvCxnSpPr>
         <p:spPr>
           <a:xfrm flipV="1">
-            <a:off x="9133754" y="2150670"/>
-            <a:ext cx="1025022" cy="3335730"/>
+            <a:off x="9001032" y="3008189"/>
+            <a:ext cx="110518" cy="2784764"/>
           </a:xfrm>
           <a:prstGeom prst="straightConnector1">
             <a:avLst/>
@@ -9484,10 +9484,10 @@
       </p:grpSpPr>
       <p:pic>
         <p:nvPicPr>
-          <p:cNvPr id="3" name="Picture 2">
+          <p:cNvPr id="4" name="Picture 3">
             <a:extLst>
               <a:ext uri="{FF2B5EF4-FFF2-40B4-BE49-F238E27FC236}">
-                <a16:creationId xmlns:a16="http://schemas.microsoft.com/office/drawing/2014/main" id="{8A6923CC-E46C-F955-5B28-FAA755917B6A}"/>
+                <a16:creationId xmlns:a16="http://schemas.microsoft.com/office/drawing/2014/main" id="{06523F9B-0DBA-31E9-F3FF-1B42732EE242}"/>
               </a:ext>
             </a:extLst>
           </p:cNvPr>
@@ -9504,8 +9504,8 @@
         </p:blipFill>
         <p:spPr>
           <a:xfrm>
-            <a:off x="4114845" y="1265459"/>
-            <a:ext cx="6718815" cy="3277069"/>
+            <a:off x="4800600" y="1219200"/>
+            <a:ext cx="4165600" cy="4419600"/>
           </a:xfrm>
           <a:prstGeom prst="rect">
             <a:avLst/>
@@ -9614,8 +9614,8 @@
         </p:nvSpPr>
         <p:spPr>
           <a:xfrm>
-            <a:off x="4114845" y="2841929"/>
-            <a:ext cx="4134075" cy="1676650"/>
+            <a:off x="4800601" y="3276600"/>
+            <a:ext cx="4038600" cy="2133600"/>
           </a:xfrm>
           <a:prstGeom prst="roundRect">
             <a:avLst/>
@@ -9663,8 +9663,8 @@
         </p:nvCxnSpPr>
         <p:spPr>
           <a:xfrm>
-            <a:off x="3657599" y="2475531"/>
-            <a:ext cx="457246" cy="1204723"/>
+            <a:off x="3657599" y="2841928"/>
+            <a:ext cx="1143002" cy="1501472"/>
           </a:xfrm>
           <a:prstGeom prst="straightConnector1">
             <a:avLst/>
@@ -9840,10 +9840,10 @@
       </p:grpSpPr>
       <p:pic>
         <p:nvPicPr>
-          <p:cNvPr id="3" name="Picture 2">
+          <p:cNvPr id="4" name="Picture 3">
             <a:extLst>
               <a:ext uri="{FF2B5EF4-FFF2-40B4-BE49-F238E27FC236}">
-                <a16:creationId xmlns:a16="http://schemas.microsoft.com/office/drawing/2014/main" id="{24A0D1C7-9D08-943D-43B6-D9E6817575C6}"/>
+                <a16:creationId xmlns:a16="http://schemas.microsoft.com/office/drawing/2014/main" id="{145F9561-7571-3225-4CCE-F8467816B036}"/>
               </a:ext>
             </a:extLst>
           </p:cNvPr>
@@ -9860,8 +9860,8 @@
         </p:blipFill>
         <p:spPr>
           <a:xfrm>
-            <a:off x="4168291" y="1143000"/>
-            <a:ext cx="7811457" cy="3810000"/>
+            <a:off x="4125738" y="1417638"/>
+            <a:ext cx="4165600" cy="4419600"/>
           </a:xfrm>
           <a:prstGeom prst="rect">
             <a:avLst/>
@@ -9910,7 +9910,7 @@
         </p:nvSpPr>
         <p:spPr>
           <a:xfrm>
-            <a:off x="1143000" y="3626562"/>
+            <a:off x="1143000" y="4410550"/>
             <a:ext cx="1876984" cy="400110"/>
           </a:xfrm>
           <a:prstGeom prst="rect">
@@ -9972,7 +9972,7 @@
         </p:nvSpPr>
         <p:spPr>
           <a:xfrm>
-            <a:off x="1143000" y="2244902"/>
+            <a:off x="1143000" y="3028890"/>
             <a:ext cx="1892675" cy="400110"/>
           </a:xfrm>
           <a:prstGeom prst="rect">
@@ -10041,7 +10041,7 @@
         </p:nvCxnSpPr>
         <p:spPr>
           <a:xfrm flipV="1">
-            <a:off x="3019984" y="3329819"/>
+            <a:off x="3019984" y="4113807"/>
             <a:ext cx="2253073" cy="496798"/>
           </a:xfrm>
           <a:prstGeom prst="straightConnector1">
@@ -10086,7 +10086,7 @@
         </p:nvCxnSpPr>
         <p:spPr>
           <a:xfrm>
-            <a:off x="3035675" y="2444957"/>
+            <a:off x="3035675" y="3228945"/>
             <a:ext cx="1532403" cy="812297"/>
           </a:xfrm>
           <a:prstGeom prst="straightConnector1">
@@ -10324,10 +10324,10 @@
       </p:grpSpPr>
       <p:pic>
         <p:nvPicPr>
-          <p:cNvPr id="3" name="Picture 2">
+          <p:cNvPr id="4" name="Picture 3">
             <a:extLst>
               <a:ext uri="{FF2B5EF4-FFF2-40B4-BE49-F238E27FC236}">
-                <a16:creationId xmlns:a16="http://schemas.microsoft.com/office/drawing/2014/main" id="{9E559DF2-B239-B28D-9892-4FAF7D66C9BB}"/>
+                <a16:creationId xmlns:a16="http://schemas.microsoft.com/office/drawing/2014/main" id="{4E42CFB2-9EE6-9886-D766-62D0B1256C55}"/>
               </a:ext>
             </a:extLst>
           </p:cNvPr>
@@ -10344,8 +10344,8 @@
         </p:blipFill>
         <p:spPr>
           <a:xfrm>
-            <a:off x="3548090" y="1178866"/>
-            <a:ext cx="9686207" cy="4724400"/>
+            <a:off x="3535218" y="1338982"/>
+            <a:ext cx="4165600" cy="4419600"/>
           </a:xfrm>
           <a:prstGeom prst="rect">
             <a:avLst/>
@@ -13355,10 +13355,10 @@
       </p:grpSpPr>
       <p:pic>
         <p:nvPicPr>
-          <p:cNvPr id="3" name="Picture 2">
+          <p:cNvPr id="4" name="Picture 3">
             <a:extLst>
               <a:ext uri="{FF2B5EF4-FFF2-40B4-BE49-F238E27FC236}">
-                <a16:creationId xmlns:a16="http://schemas.microsoft.com/office/drawing/2014/main" id="{D68ED950-9CE4-D554-1088-4244596595D7}"/>
+                <a16:creationId xmlns:a16="http://schemas.microsoft.com/office/drawing/2014/main" id="{1586E826-EAD8-772C-9BA8-7894B74A6563}"/>
               </a:ext>
             </a:extLst>
           </p:cNvPr>
@@ -13375,8 +13375,8 @@
         </p:blipFill>
         <p:spPr>
           <a:xfrm>
-            <a:off x="4876800" y="1143000"/>
-            <a:ext cx="8763192" cy="4274204"/>
+            <a:off x="5215082" y="1424565"/>
+            <a:ext cx="4165600" cy="4419600"/>
           </a:xfrm>
           <a:prstGeom prst="rect">
             <a:avLst/>
@@ -13475,8 +13475,8 @@
         </p:nvSpPr>
         <p:spPr>
           <a:xfrm>
-            <a:off x="5067300" y="4202393"/>
-            <a:ext cx="5676900" cy="826807"/>
+            <a:off x="5088082" y="4606628"/>
+            <a:ext cx="4436918" cy="826807"/>
           </a:xfrm>
           <a:prstGeom prst="roundRect">
             <a:avLst/>
@@ -13520,7 +13520,7 @@
         <p:spPr>
           <a:xfrm>
             <a:off x="4038600" y="3964634"/>
-            <a:ext cx="1049482" cy="528594"/>
+            <a:ext cx="1049482" cy="826807"/>
           </a:xfrm>
           <a:prstGeom prst="straightConnector1">
             <a:avLst/>
@@ -16138,10 +16138,10 @@
       </p:grpSpPr>
       <p:pic>
         <p:nvPicPr>
-          <p:cNvPr id="3" name="Picture 2">
+          <p:cNvPr id="4" name="Picture 3">
             <a:extLst>
               <a:ext uri="{FF2B5EF4-FFF2-40B4-BE49-F238E27FC236}">
-                <a16:creationId xmlns:a16="http://schemas.microsoft.com/office/drawing/2014/main" id="{9A94FEEC-31A1-6D75-D249-AFBE33C3A163}"/>
+                <a16:creationId xmlns:a16="http://schemas.microsoft.com/office/drawing/2014/main" id="{6C920A72-EE07-9098-2DA8-95199DF4584D}"/>
               </a:ext>
             </a:extLst>
           </p:cNvPr>
@@ -16158,8 +16158,8 @@
         </p:blipFill>
         <p:spPr>
           <a:xfrm>
-            <a:off x="4343400" y="1383002"/>
-            <a:ext cx="8230803" cy="4014534"/>
+            <a:off x="4876800" y="1752600"/>
+            <a:ext cx="4165600" cy="4419600"/>
           </a:xfrm>
           <a:prstGeom prst="rect">
             <a:avLst/>
@@ -16307,7 +16307,7 @@
         </p:nvSpPr>
         <p:spPr>
           <a:xfrm flipV="1">
-            <a:off x="4343400" y="4969268"/>
+            <a:off x="4876800" y="5715000"/>
             <a:ext cx="2209801" cy="381000"/>
           </a:xfrm>
           <a:prstGeom prst="roundRect">
@@ -16357,7 +16357,7 @@
         <p:spPr>
           <a:xfrm>
             <a:off x="3561230" y="3429000"/>
-            <a:ext cx="915517" cy="1540268"/>
+            <a:ext cx="1315570" cy="2286000"/>
           </a:xfrm>
           <a:prstGeom prst="straightConnector1">
             <a:avLst/>
@@ -18701,6 +18701,36 @@
           <a:chExt cx="0" cy="0"/>
         </a:xfrm>
       </p:grpSpPr>
+      <p:pic>
+        <p:nvPicPr>
+          <p:cNvPr id="6" name="Picture 5">
+            <a:extLst>
+              <a:ext uri="{FF2B5EF4-FFF2-40B4-BE49-F238E27FC236}">
+                <a16:creationId xmlns:a16="http://schemas.microsoft.com/office/drawing/2014/main" id="{AC79F776-E3C3-E28D-2C8A-F9F15157BCA4}"/>
+              </a:ext>
+            </a:extLst>
+          </p:cNvPr>
+          <p:cNvPicPr>
+            <a:picLocks noChangeAspect="1"/>
+          </p:cNvPicPr>
+          <p:nvPr/>
+        </p:nvPicPr>
+        <p:blipFill>
+          <a:blip r:embed="rId3"/>
+          <a:stretch>
+            <a:fillRect/>
+          </a:stretch>
+        </p:blipFill>
+        <p:spPr>
+          <a:xfrm>
+            <a:off x="4013200" y="1752600"/>
+            <a:ext cx="4165600" cy="4419600"/>
+          </a:xfrm>
+          <a:prstGeom prst="rect">
+            <a:avLst/>
+          </a:prstGeom>
+        </p:spPr>
+      </p:pic>
       <p:graphicFrame>
         <p:nvGraphicFramePr>
           <p:cNvPr id="4" name="Table 3">
@@ -18954,36 +18984,6 @@
           </a:fontRef>
         </p:style>
       </p:cxnSp>
-      <p:pic>
-        <p:nvPicPr>
-          <p:cNvPr id="3" name="Picture 2">
-            <a:extLst>
-              <a:ext uri="{FF2B5EF4-FFF2-40B4-BE49-F238E27FC236}">
-                <a16:creationId xmlns:a16="http://schemas.microsoft.com/office/drawing/2014/main" id="{34D394E0-9F2F-27D7-22D3-ED4E01D518B0}"/>
-              </a:ext>
-            </a:extLst>
-          </p:cNvPr>
-          <p:cNvPicPr>
-            <a:picLocks noChangeAspect="1"/>
-          </p:cNvPicPr>
-          <p:nvPr/>
-        </p:nvPicPr>
-        <p:blipFill>
-          <a:blip r:embed="rId3"/>
-          <a:stretch>
-            <a:fillRect/>
-          </a:stretch>
-        </p:blipFill>
-        <p:spPr>
-          <a:xfrm>
-            <a:off x="4249783" y="1923130"/>
-            <a:ext cx="9522753" cy="4644676"/>
-          </a:xfrm>
-          <a:prstGeom prst="rect">
-            <a:avLst/>
-          </a:prstGeom>
-        </p:spPr>
-      </p:pic>
     </p:spTree>
     <p:extLst>
       <p:ext uri="{BB962C8B-B14F-4D97-AF65-F5344CB8AC3E}">
@@ -20176,10 +20176,10 @@
       </p:grpSpPr>
       <p:pic>
         <p:nvPicPr>
-          <p:cNvPr id="3" name="Picture 2">
+          <p:cNvPr id="6" name="Picture 5">
             <a:extLst>
               <a:ext uri="{FF2B5EF4-FFF2-40B4-BE49-F238E27FC236}">
-                <a16:creationId xmlns:a16="http://schemas.microsoft.com/office/drawing/2014/main" id="{10B80157-96A0-FB64-2D5D-D4A4DA266EA3}"/>
+                <a16:creationId xmlns:a16="http://schemas.microsoft.com/office/drawing/2014/main" id="{775E06CB-0EC0-2E4A-AFEE-7D86B74FB83A}"/>
               </a:ext>
             </a:extLst>
           </p:cNvPr>
@@ -20196,8 +20196,8 @@
         </p:blipFill>
         <p:spPr>
           <a:xfrm>
-            <a:off x="4934309" y="1676400"/>
-            <a:ext cx="7967686" cy="3886200"/>
+            <a:off x="4898683" y="1471671"/>
+            <a:ext cx="4165600" cy="4419600"/>
           </a:xfrm>
           <a:prstGeom prst="rect">
             <a:avLst/>
@@ -20651,8 +20651,8 @@
         </p:nvSpPr>
         <p:spPr>
           <a:xfrm>
-            <a:off x="4912538" y="2278171"/>
-            <a:ext cx="4328905" cy="831933"/>
+            <a:off x="4912539" y="2278171"/>
+            <a:ext cx="3850462" cy="831933"/>
           </a:xfrm>
           <a:prstGeom prst="rect">
             <a:avLst/>
@@ -21021,10 +21021,10 @@
       </p:grpSpPr>
       <p:pic>
         <p:nvPicPr>
-          <p:cNvPr id="3" name="Picture 2">
+          <p:cNvPr id="6" name="Picture 5">
             <a:extLst>
               <a:ext uri="{FF2B5EF4-FFF2-40B4-BE49-F238E27FC236}">
-                <a16:creationId xmlns:a16="http://schemas.microsoft.com/office/drawing/2014/main" id="{5307DD5E-631A-DB71-33E6-F7C119DECEB8}"/>
+                <a16:creationId xmlns:a16="http://schemas.microsoft.com/office/drawing/2014/main" id="{307C73D1-CA82-8018-8703-5144056C6C81}"/>
               </a:ext>
             </a:extLst>
           </p:cNvPr>
@@ -21041,8 +21041,8 @@
         </p:blipFill>
         <p:spPr>
           <a:xfrm>
-            <a:off x="5847806" y="1517865"/>
-            <a:ext cx="9457657" cy="4612926"/>
+            <a:off x="5937860" y="1733677"/>
+            <a:ext cx="4165600" cy="4419600"/>
           </a:xfrm>
           <a:prstGeom prst="rect">
             <a:avLst/>
@@ -21623,7 +21623,7 @@
         <p:spPr>
           <a:xfrm>
             <a:off x="5943599" y="2209800"/>
-            <a:ext cx="4368729" cy="1139476"/>
+            <a:ext cx="3962401" cy="1139476"/>
           </a:xfrm>
           <a:prstGeom prst="rect">
             <a:avLst/>
@@ -21668,8 +21668,8 @@
         </p:nvSpPr>
         <p:spPr>
           <a:xfrm>
-            <a:off x="5974082" y="3943477"/>
-            <a:ext cx="5989318" cy="1828799"/>
+            <a:off x="5974082" y="4076700"/>
+            <a:ext cx="3931918" cy="1638300"/>
           </a:xfrm>
           <a:prstGeom prst="rect">
             <a:avLst/>
@@ -27788,10 +27788,10 @@
       </p:grpSpPr>
       <p:pic>
         <p:nvPicPr>
-          <p:cNvPr id="3" name="Picture 2">
+          <p:cNvPr id="4" name="Picture 3">
             <a:extLst>
               <a:ext uri="{FF2B5EF4-FFF2-40B4-BE49-F238E27FC236}">
-                <a16:creationId xmlns:a16="http://schemas.microsoft.com/office/drawing/2014/main" id="{95F8E40A-BD9C-FA7E-E71C-9C64BE6D6D78}"/>
+                <a16:creationId xmlns:a16="http://schemas.microsoft.com/office/drawing/2014/main" id="{3C3E19E4-D88E-381F-A522-4FDAAA6E0B14}"/>
               </a:ext>
             </a:extLst>
           </p:cNvPr>
@@ -27808,8 +27808,8 @@
         </p:blipFill>
         <p:spPr>
           <a:xfrm>
-            <a:off x="5795963" y="2032971"/>
-            <a:ext cx="5181600" cy="2527300"/>
+            <a:off x="6489699" y="2018030"/>
+            <a:ext cx="4165600" cy="4419600"/>
           </a:xfrm>
           <a:prstGeom prst="rect">
             <a:avLst/>
@@ -28102,9 +28102,9 @@
           <p:nvPr/>
         </p:nvCxnSpPr>
         <p:spPr>
-          <a:xfrm flipV="1">
-            <a:off x="5290483" y="3895388"/>
-            <a:ext cx="505480" cy="664884"/>
+          <a:xfrm>
+            <a:off x="5290483" y="4560272"/>
+            <a:ext cx="1199216" cy="230832"/>
           </a:xfrm>
           <a:prstGeom prst="straightConnector1">
             <a:avLst/>
@@ -28317,8 +28317,8 @@
         </p:nvCxnSpPr>
         <p:spPr>
           <a:xfrm flipV="1">
-            <a:off x="5098156" y="2695429"/>
-            <a:ext cx="697807" cy="798614"/>
+            <a:off x="5098156" y="3279056"/>
+            <a:ext cx="1531244" cy="214987"/>
           </a:xfrm>
           <a:prstGeom prst="straightConnector1">
             <a:avLst/>

</xml_diff>